<commit_message>
Adding content to slides
</commit_message>
<xml_diff>
--- a/Predicting Air Quality in Salt Lake City PowerPoint.pptx
+++ b/Predicting Air Quality in Salt Lake City PowerPoint.pptx
@@ -6,12 +6,16 @@
   </p:sldMasterIdLst>
   <p:sldIdLst>
     <p:sldId id="256" r:id="rId2"/>
-    <p:sldId id="257" r:id="rId3"/>
-    <p:sldId id="258" r:id="rId4"/>
-    <p:sldId id="259" r:id="rId5"/>
-    <p:sldId id="260" r:id="rId6"/>
-    <p:sldId id="261" r:id="rId7"/>
-    <p:sldId id="262" r:id="rId8"/>
+    <p:sldId id="263" r:id="rId3"/>
+    <p:sldId id="264" r:id="rId4"/>
+    <p:sldId id="265" r:id="rId5"/>
+    <p:sldId id="258" r:id="rId6"/>
+    <p:sldId id="266" r:id="rId7"/>
+    <p:sldId id="267" r:id="rId8"/>
+    <p:sldId id="268" r:id="rId9"/>
+    <p:sldId id="269" r:id="rId10"/>
+    <p:sldId id="270" r:id="rId11"/>
+    <p:sldId id="262" r:id="rId12"/>
   </p:sldIdLst>
   <p:sldSz cx="12192000" cy="6858000"/>
   <p:notesSz cx="6858000" cy="9144000"/>
@@ -110,6 +114,11 @@
       </a:defRPr>
     </a:lvl9pPr>
   </p:defaultTextStyle>
+  <p:extLst>
+    <p:ext uri="{EFAFB233-063F-42B5-8137-9DF3F51BA10A}">
+      <p15:sldGuideLst xmlns:p15="http://schemas.microsoft.com/office/powerpoint/2012/main"/>
+    </p:ext>
+  </p:extLst>
 </p:presentation>
 </file>
 
@@ -208,7 +217,7 @@
           <a:effectLst/>
           <a:extLst>
             <a:ext uri="{91240B29-F687-4f45-9708-019B960494DF}">
-              <a14:hiddenLine xmlns:a14="http://schemas.microsoft.com/office/drawing/2010/main" xmlns="" w="9525">
+              <a14:hiddenLine xmlns="" xmlns:a14="http://schemas.microsoft.com/office/drawing/2010/main" w="9525">
                 <a:solidFill>
                   <a:srgbClr val="000000"/>
                 </a:solidFill>
@@ -1718,7 +1727,7 @@
           <a:ln/>
           <a:extLst>
             <a:ext uri="{91240B29-F687-4f45-9708-019B960494DF}">
-              <a14:hiddenLine xmlns:a14="http://schemas.microsoft.com/office/drawing/2010/main" xmlns="" w="9525">
+              <a14:hiddenLine xmlns="" xmlns:a14="http://schemas.microsoft.com/office/drawing/2010/main" w="9525">
                 <a:solidFill>
                   <a:srgbClr val="000000"/>
                 </a:solidFill>
@@ -1990,7 +1999,7 @@
           <a:ln/>
           <a:extLst>
             <a:ext uri="{91240B29-F687-4f45-9708-019B960494DF}">
-              <a14:hiddenLine xmlns:a14="http://schemas.microsoft.com/office/drawing/2010/main" xmlns="" w="9525">
+              <a14:hiddenLine xmlns="" xmlns:a14="http://schemas.microsoft.com/office/drawing/2010/main" w="9525">
                 <a:solidFill>
                   <a:srgbClr val="000000"/>
                 </a:solidFill>
@@ -2270,7 +2279,7 @@
           <a:ln/>
           <a:extLst>
             <a:ext uri="{91240B29-F687-4f45-9708-019B960494DF}">
-              <a14:hiddenLine xmlns:a14="http://schemas.microsoft.com/office/drawing/2010/main" xmlns="" w="9525">
+              <a14:hiddenLine xmlns="" xmlns:a14="http://schemas.microsoft.com/office/drawing/2010/main" w="9525">
                 <a:solidFill>
                   <a:srgbClr val="000000"/>
                 </a:solidFill>
@@ -2890,7 +2899,7 @@
           <a:ln/>
           <a:extLst>
             <a:ext uri="{91240B29-F687-4f45-9708-019B960494DF}">
-              <a14:hiddenLine xmlns:a14="http://schemas.microsoft.com/office/drawing/2010/main" xmlns="" w="9525">
+              <a14:hiddenLine xmlns="" xmlns:a14="http://schemas.microsoft.com/office/drawing/2010/main" w="9525">
                 <a:solidFill>
                   <a:srgbClr val="000000"/>
                 </a:solidFill>
@@ -3226,7 +3235,7 @@
           <a:ln/>
           <a:extLst>
             <a:ext uri="{91240B29-F687-4f45-9708-019B960494DF}">
-              <a14:hiddenLine xmlns:a14="http://schemas.microsoft.com/office/drawing/2010/main" xmlns="" w="9525">
+              <a14:hiddenLine xmlns="" xmlns:a14="http://schemas.microsoft.com/office/drawing/2010/main" w="9525">
                 <a:solidFill>
                   <a:srgbClr val="000000"/>
                 </a:solidFill>
@@ -3700,7 +3709,7 @@
           <a:ln/>
           <a:extLst>
             <a:ext uri="{91240B29-F687-4f45-9708-019B960494DF}">
-              <a14:hiddenLine xmlns:a14="http://schemas.microsoft.com/office/drawing/2010/main" xmlns="" w="9525">
+              <a14:hiddenLine xmlns="" xmlns:a14="http://schemas.microsoft.com/office/drawing/2010/main" w="9525">
                 <a:solidFill>
                   <a:srgbClr val="000000"/>
                 </a:solidFill>
@@ -4123,7 +4132,7 @@
           <a:ln/>
           <a:extLst>
             <a:ext uri="{91240B29-F687-4f45-9708-019B960494DF}">
-              <a14:hiddenLine xmlns:a14="http://schemas.microsoft.com/office/drawing/2010/main" xmlns="" w="9525">
+              <a14:hiddenLine xmlns="" xmlns:a14="http://schemas.microsoft.com/office/drawing/2010/main" w="9525">
                 <a:solidFill>
                   <a:srgbClr val="000000"/>
                 </a:solidFill>
@@ -5438,6 +5447,155 @@
 </p:sld>
 </file>
 
+<file path=ppt/slides/slide10.xml><?xml version="1.0" encoding="utf-8"?>
+<p:sld xmlns:a="http://schemas.openxmlformats.org/drawingml/2006/main" xmlns:r="http://schemas.openxmlformats.org/officeDocument/2006/relationships" xmlns:p="http://schemas.openxmlformats.org/presentationml/2006/main">
+  <p:cSld>
+    <p:spTree>
+      <p:nvGrpSpPr>
+        <p:cNvPr id="1" name=""/>
+        <p:cNvGrpSpPr/>
+        <p:nvPr/>
+      </p:nvGrpSpPr>
+      <p:grpSpPr>
+        <a:xfrm>
+          <a:off x="0" y="0"/>
+          <a:ext cx="0" cy="0"/>
+          <a:chOff x="0" y="0"/>
+          <a:chExt cx="0" cy="0"/>
+        </a:xfrm>
+      </p:grpSpPr>
+      <p:sp>
+        <p:nvSpPr>
+          <p:cNvPr id="2" name="Title 1"/>
+          <p:cNvSpPr>
+            <a:spLocks noGrp="1"/>
+          </p:cNvSpPr>
+          <p:nvPr>
+            <p:ph type="title"/>
+          </p:nvPr>
+        </p:nvSpPr>
+        <p:spPr/>
+        <p:txBody>
+          <a:bodyPr/>
+          <a:lstStyle/>
+          <a:p>
+            <a:r>
+              <a:rPr lang="en-US" sz="6000" dirty="0"/>
+              <a:t>Results</a:t>
+            </a:r>
+          </a:p>
+        </p:txBody>
+      </p:sp>
+      <p:sp>
+        <p:nvSpPr>
+          <p:cNvPr id="3" name="Text Placeholder 2"/>
+          <p:cNvSpPr>
+            <a:spLocks noGrp="1"/>
+          </p:cNvSpPr>
+          <p:nvPr>
+            <p:ph type="body" idx="1"/>
+          </p:nvPr>
+        </p:nvSpPr>
+        <p:spPr/>
+        <p:txBody>
+          <a:bodyPr/>
+          <a:lstStyle/>
+          <a:p>
+            <a:endParaRPr lang="en-US" dirty="0"/>
+          </a:p>
+        </p:txBody>
+      </p:sp>
+    </p:spTree>
+    <p:extLst>
+      <p:ext uri="{BB962C8B-B14F-4D97-AF65-F5344CB8AC3E}">
+        <p14:creationId xmlns:p14="http://schemas.microsoft.com/office/powerpoint/2010/main" val="3332299719"/>
+      </p:ext>
+    </p:extLst>
+  </p:cSld>
+  <p:clrMapOvr>
+    <a:masterClrMapping/>
+  </p:clrMapOvr>
+</p:sld>
+</file>
+
+<file path=ppt/slides/slide11.xml><?xml version="1.0" encoding="utf-8"?>
+<p:sld xmlns:a="http://schemas.openxmlformats.org/drawingml/2006/main" xmlns:r="http://schemas.openxmlformats.org/officeDocument/2006/relationships" xmlns:p="http://schemas.openxmlformats.org/presentationml/2006/main">
+  <p:cSld>
+    <p:spTree>
+      <p:nvGrpSpPr>
+        <p:cNvPr id="1" name=""/>
+        <p:cNvGrpSpPr/>
+        <p:nvPr/>
+      </p:nvGrpSpPr>
+      <p:grpSpPr>
+        <a:xfrm>
+          <a:off x="0" y="0"/>
+          <a:ext cx="0" cy="0"/>
+          <a:chOff x="0" y="0"/>
+          <a:chExt cx="0" cy="0"/>
+        </a:xfrm>
+      </p:grpSpPr>
+      <p:sp>
+        <p:nvSpPr>
+          <p:cNvPr id="2" name="Title 1"/>
+          <p:cNvSpPr>
+            <a:spLocks noGrp="1"/>
+          </p:cNvSpPr>
+          <p:nvPr>
+            <p:ph type="title"/>
+          </p:nvPr>
+        </p:nvSpPr>
+        <p:spPr/>
+        <p:txBody>
+          <a:bodyPr anchor="ctr"/>
+          <a:lstStyle/>
+          <a:p>
+            <a:pPr algn="ctr"/>
+            <a:r>
+              <a:rPr lang="en-US" sz="5400" dirty="0"/>
+              <a:t>Thank you for your time</a:t>
+            </a:r>
+          </a:p>
+        </p:txBody>
+      </p:sp>
+      <p:sp>
+        <p:nvSpPr>
+          <p:cNvPr id="3" name="Text Placeholder 2"/>
+          <p:cNvSpPr>
+            <a:spLocks noGrp="1"/>
+          </p:cNvSpPr>
+          <p:nvPr>
+            <p:ph type="body" sz="quarter" idx="16"/>
+          </p:nvPr>
+        </p:nvSpPr>
+        <p:spPr/>
+        <p:txBody>
+          <a:bodyPr anchor="ctr">
+            <a:normAutofit/>
+          </a:bodyPr>
+          <a:lstStyle/>
+          <a:p>
+            <a:pPr algn="ctr"/>
+            <a:r>
+              <a:rPr lang="en-US" sz="6000" dirty="0"/>
+              <a:t>Questions?</a:t>
+            </a:r>
+          </a:p>
+        </p:txBody>
+      </p:sp>
+    </p:spTree>
+    <p:extLst>
+      <p:ext uri="{BB962C8B-B14F-4D97-AF65-F5344CB8AC3E}">
+        <p14:creationId xmlns:p14="http://schemas.microsoft.com/office/powerpoint/2010/main" val="2961838120"/>
+      </p:ext>
+    </p:extLst>
+  </p:cSld>
+  <p:clrMapOvr>
+    <a:masterClrMapping/>
+  </p:clrMapOvr>
+</p:sld>
+</file>
+
 <file path=ppt/slides/slide2.xml><?xml version="1.0" encoding="utf-8"?>
 <p:sld xmlns:a="http://schemas.openxmlformats.org/drawingml/2006/main" xmlns:r="http://schemas.openxmlformats.org/officeDocument/2006/relationships" xmlns:p="http://schemas.openxmlformats.org/presentationml/2006/main">
   <p:cSld>
@@ -5471,35 +5629,39 @@
           <a:lstStyle/>
           <a:p>
             <a:r>
+              <a:rPr lang="en-US" sz="6600" dirty="0"/>
+              <a:t>Objective</a:t>
+            </a:r>
+            <a:endParaRPr lang="en-US" sz="6600" dirty="0"/>
+          </a:p>
+        </p:txBody>
+      </p:sp>
+      <p:sp>
+        <p:nvSpPr>
+          <p:cNvPr id="3" name="Text Placeholder 2"/>
+          <p:cNvSpPr>
+            <a:spLocks noGrp="1"/>
+          </p:cNvSpPr>
+          <p:nvPr>
+            <p:ph type="body" idx="1"/>
+          </p:nvPr>
+        </p:nvSpPr>
+        <p:spPr/>
+        <p:txBody>
+          <a:bodyPr/>
+          <a:lstStyle/>
+          <a:p>
+            <a:r>
               <a:rPr lang="en-US" dirty="0"/>
-              <a:t>The Idea</a:t>
-            </a:r>
-          </a:p>
-        </p:txBody>
-      </p:sp>
-      <p:sp>
-        <p:nvSpPr>
-          <p:cNvPr id="3" name="Content Placeholder 2"/>
-          <p:cNvSpPr>
-            <a:spLocks noGrp="1"/>
-          </p:cNvSpPr>
-          <p:nvPr>
-            <p:ph idx="1"/>
-          </p:nvPr>
-        </p:nvSpPr>
-        <p:spPr/>
-        <p:txBody>
-          <a:bodyPr/>
-          <a:lstStyle/>
-          <a:p>
-            <a:endParaRPr lang="en-US" dirty="0"/>
+              <a:t>Create an air quality forecast for Salt Lake City </a:t>
+            </a:r>
           </a:p>
         </p:txBody>
       </p:sp>
     </p:spTree>
     <p:extLst>
       <p:ext uri="{BB962C8B-B14F-4D97-AF65-F5344CB8AC3E}">
-        <p14:creationId xmlns:p14="http://schemas.microsoft.com/office/powerpoint/2010/main" val="3422452107"/>
+        <p14:creationId xmlns:p14="http://schemas.microsoft.com/office/powerpoint/2010/main" val="1098480779"/>
       </p:ext>
     </p:extLst>
   </p:cSld>
@@ -5538,39 +5700,69 @@
         </p:nvSpPr>
         <p:spPr/>
         <p:txBody>
-          <a:bodyPr/>
-          <a:lstStyle/>
-          <a:p>
-            <a:r>
-              <a:rPr lang="en-US" dirty="0"/>
-              <a:t>Data Sources, Collection, and Cleaning</a:t>
-            </a:r>
-          </a:p>
-        </p:txBody>
-      </p:sp>
-      <p:sp>
-        <p:nvSpPr>
-          <p:cNvPr id="3" name="Content Placeholder 2"/>
-          <p:cNvSpPr>
-            <a:spLocks noGrp="1"/>
-          </p:cNvSpPr>
+          <a:bodyPr anchor="ctr"/>
+          <a:lstStyle/>
+          <a:p>
+            <a:pPr algn="ctr"/>
+            <a:r>
+              <a:rPr lang="en-US" sz="4000" dirty="0"/>
+              <a:t>The Idea</a:t>
+            </a:r>
+          </a:p>
+        </p:txBody>
+      </p:sp>
+      <p:pic>
+        <p:nvPicPr>
+          <p:cNvPr id="5" name="Content Placeholder 4"/>
+          <p:cNvPicPr>
+            <a:picLocks noGrp="1" noChangeAspect="1"/>
+          </p:cNvPicPr>
           <p:nvPr>
             <p:ph idx="1"/>
           </p:nvPr>
+        </p:nvPicPr>
+        <p:blipFill>
+          <a:blip r:embed="rId2"/>
+          <a:stretch>
+            <a:fillRect/>
+          </a:stretch>
+        </p:blipFill>
+        <p:spPr>
+          <a:xfrm>
+            <a:off x="4801453" y="1255286"/>
+            <a:ext cx="6960479" cy="3921070"/>
+          </a:xfrm>
+        </p:spPr>
+      </p:pic>
+      <p:sp>
+        <p:nvSpPr>
+          <p:cNvPr id="4" name="Text Placeholder 3"/>
+          <p:cNvSpPr>
+            <a:spLocks noGrp="1"/>
+          </p:cNvSpPr>
+          <p:nvPr>
+            <p:ph type="body" sz="half" idx="2"/>
+          </p:nvPr>
         </p:nvSpPr>
         <p:spPr/>
         <p:txBody>
-          <a:bodyPr/>
-          <a:lstStyle/>
-          <a:p>
-            <a:endParaRPr lang="en-US"/>
+          <a:bodyPr>
+            <a:noAutofit/>
+          </a:bodyPr>
+          <a:lstStyle/>
+          <a:p>
+            <a:r>
+              <a:rPr lang="en-US" sz="1700" dirty="0"/>
+              <a:t>Our primary objective is to devise a model to obtain an air quality forecast much like we have a weather forecast. We did not find any source for an air quality forecast that goes beyond one day.  A short term model can be useful in warning sensitive groups of upcoming poor air quality days.  As a result, we decided to do a five day forecast. </a:t>
+            </a:r>
+            <a:endParaRPr lang="en-US" sz="1700" dirty="0"/>
           </a:p>
         </p:txBody>
       </p:sp>
     </p:spTree>
     <p:extLst>
       <p:ext uri="{BB962C8B-B14F-4D97-AF65-F5344CB8AC3E}">
-        <p14:creationId xmlns:p14="http://schemas.microsoft.com/office/powerpoint/2010/main" val="2013565401"/>
+        <p14:creationId xmlns:p14="http://schemas.microsoft.com/office/powerpoint/2010/main" val="3134956732"/>
       </p:ext>
     </p:extLst>
   </p:cSld>
@@ -5607,6 +5799,34 @@
             <p:ph type="title"/>
           </p:nvPr>
         </p:nvSpPr>
+        <p:spPr>
+          <a:xfrm>
+            <a:off x="6008914" y="2951396"/>
+            <a:ext cx="5362504" cy="1468800"/>
+          </a:xfrm>
+        </p:spPr>
+        <p:txBody>
+          <a:bodyPr/>
+          <a:lstStyle/>
+          <a:p>
+            <a:r>
+              <a:rPr lang="en-US" sz="6000" dirty="0"/>
+              <a:t>Data Sources, Collection, and Cleaning</a:t>
+            </a:r>
+            <a:endParaRPr lang="en-US" sz="6000" dirty="0"/>
+          </a:p>
+        </p:txBody>
+      </p:sp>
+      <p:sp>
+        <p:nvSpPr>
+          <p:cNvPr id="3" name="Text Placeholder 2"/>
+          <p:cNvSpPr>
+            <a:spLocks noGrp="1"/>
+          </p:cNvSpPr>
+          <p:nvPr>
+            <p:ph type="body" idx="1"/>
+          </p:nvPr>
+        </p:nvSpPr>
         <p:spPr/>
         <p:txBody>
           <a:bodyPr/>
@@ -5614,34 +5834,15 @@
           <a:p>
             <a:r>
               <a:rPr lang="en-US" dirty="0"/>
-              <a:t>Preliminary Analysis</a:t>
-            </a:r>
-          </a:p>
-        </p:txBody>
-      </p:sp>
-      <p:sp>
-        <p:nvSpPr>
-          <p:cNvPr id="3" name="Content Placeholder 2"/>
-          <p:cNvSpPr>
-            <a:spLocks noGrp="1"/>
-          </p:cNvSpPr>
-          <p:nvPr>
-            <p:ph idx="1"/>
-          </p:nvPr>
-        </p:nvSpPr>
-        <p:spPr/>
-        <p:txBody>
-          <a:bodyPr/>
-          <a:lstStyle/>
-          <a:p>
-            <a:endParaRPr lang="en-US"/>
+              <a:t>What data do we use, how do we collect it, and how do we organize it for analysis</a:t>
+            </a:r>
           </a:p>
         </p:txBody>
       </p:sp>
     </p:spTree>
     <p:extLst>
       <p:ext uri="{BB962C8B-B14F-4D97-AF65-F5344CB8AC3E}">
-        <p14:creationId xmlns:p14="http://schemas.microsoft.com/office/powerpoint/2010/main" val="1921106764"/>
+        <p14:creationId xmlns:p14="http://schemas.microsoft.com/office/powerpoint/2010/main" val="1860038862"/>
       </p:ext>
     </p:extLst>
   </p:cSld>
@@ -5684,8 +5885,8 @@
           <a:lstStyle/>
           <a:p>
             <a:r>
-              <a:rPr lang="en-US" dirty="0"/>
-              <a:t>Model Selection</a:t>
+              <a:rPr lang="en-US" sz="6000" dirty="0"/>
+              <a:t>Data Sources</a:t>
             </a:r>
           </a:p>
         </p:txBody>
@@ -5705,14 +5906,14 @@
           <a:bodyPr/>
           <a:lstStyle/>
           <a:p>
-            <a:endParaRPr lang="en-US"/>
+            <a:endParaRPr lang="en-US" dirty="0"/>
           </a:p>
         </p:txBody>
       </p:sp>
     </p:spTree>
     <p:extLst>
       <p:ext uri="{BB962C8B-B14F-4D97-AF65-F5344CB8AC3E}">
-        <p14:creationId xmlns:p14="http://schemas.microsoft.com/office/powerpoint/2010/main" val="1040328746"/>
+        <p14:creationId xmlns:p14="http://schemas.microsoft.com/office/powerpoint/2010/main" val="2013565401"/>
       </p:ext>
     </p:extLst>
   </p:cSld>
@@ -5755,8 +5956,8 @@
           <a:lstStyle/>
           <a:p>
             <a:r>
-              <a:rPr lang="en-US" dirty="0"/>
-              <a:t>Results</a:t>
+              <a:rPr lang="en-US" sz="6000" dirty="0"/>
+              <a:t>Data Collection</a:t>
             </a:r>
           </a:p>
         </p:txBody>
@@ -5783,7 +5984,7 @@
     </p:spTree>
     <p:extLst>
       <p:ext uri="{BB962C8B-B14F-4D97-AF65-F5344CB8AC3E}">
-        <p14:creationId xmlns:p14="http://schemas.microsoft.com/office/powerpoint/2010/main" val="337747022"/>
+        <p14:creationId xmlns:p14="http://schemas.microsoft.com/office/powerpoint/2010/main" val="629659559"/>
       </p:ext>
     </p:extLst>
   </p:cSld>
@@ -5826,45 +6027,177 @@
           <a:lstStyle/>
           <a:p>
             <a:r>
-              <a:rPr lang="en-US" sz="4800" dirty="0"/>
-              <a:t>Thank you for your time</a:t>
-            </a:r>
-          </a:p>
-        </p:txBody>
-      </p:sp>
-      <p:sp>
-        <p:nvSpPr>
-          <p:cNvPr id="3" name="Text Placeholder 2"/>
-          <p:cNvSpPr>
-            <a:spLocks noGrp="1"/>
-          </p:cNvSpPr>
-          <p:nvPr>
-            <p:ph type="body" sz="quarter" idx="16"/>
+              <a:rPr lang="en-US" sz="6000" dirty="0"/>
+              <a:t>Data Cleaning</a:t>
+            </a:r>
+          </a:p>
+        </p:txBody>
+      </p:sp>
+      <p:sp>
+        <p:nvSpPr>
+          <p:cNvPr id="3" name="Content Placeholder 2"/>
+          <p:cNvSpPr>
+            <a:spLocks noGrp="1"/>
+          </p:cNvSpPr>
+          <p:nvPr>
+            <p:ph idx="1"/>
           </p:nvPr>
         </p:nvSpPr>
         <p:spPr/>
         <p:txBody>
-          <a:bodyPr>
-            <a:normAutofit/>
-          </a:bodyPr>
-          <a:lstStyle/>
-          <a:p>
-            <a:pPr>
-              <a:lnSpc>
-                <a:spcPct val="250000"/>
-              </a:lnSpc>
-            </a:pPr>
-            <a:r>
-              <a:rPr lang="en-US" sz="4800" dirty="0"/>
-              <a:t>Questions?</a:t>
-            </a:r>
+          <a:bodyPr/>
+          <a:lstStyle/>
+          <a:p>
+            <a:endParaRPr lang="en-US"/>
           </a:p>
         </p:txBody>
       </p:sp>
     </p:spTree>
     <p:extLst>
       <p:ext uri="{BB962C8B-B14F-4D97-AF65-F5344CB8AC3E}">
-        <p14:creationId xmlns:p14="http://schemas.microsoft.com/office/powerpoint/2010/main" val="2961838120"/>
+        <p14:creationId xmlns:p14="http://schemas.microsoft.com/office/powerpoint/2010/main" val="2138150528"/>
+      </p:ext>
+    </p:extLst>
+  </p:cSld>
+  <p:clrMapOvr>
+    <a:masterClrMapping/>
+  </p:clrMapOvr>
+</p:sld>
+</file>
+
+<file path=ppt/slides/slide8.xml><?xml version="1.0" encoding="utf-8"?>
+<p:sld xmlns:a="http://schemas.openxmlformats.org/drawingml/2006/main" xmlns:r="http://schemas.openxmlformats.org/officeDocument/2006/relationships" xmlns:p="http://schemas.openxmlformats.org/presentationml/2006/main">
+  <p:cSld>
+    <p:spTree>
+      <p:nvGrpSpPr>
+        <p:cNvPr id="1" name=""/>
+        <p:cNvGrpSpPr/>
+        <p:nvPr/>
+      </p:nvGrpSpPr>
+      <p:grpSpPr>
+        <a:xfrm>
+          <a:off x="0" y="0"/>
+          <a:ext cx="0" cy="0"/>
+          <a:chOff x="0" y="0"/>
+          <a:chExt cx="0" cy="0"/>
+        </a:xfrm>
+      </p:grpSpPr>
+      <p:sp>
+        <p:nvSpPr>
+          <p:cNvPr id="2" name="Title 1"/>
+          <p:cNvSpPr>
+            <a:spLocks noGrp="1"/>
+          </p:cNvSpPr>
+          <p:nvPr>
+            <p:ph type="title"/>
+          </p:nvPr>
+        </p:nvSpPr>
+        <p:spPr/>
+        <p:txBody>
+          <a:bodyPr/>
+          <a:lstStyle/>
+          <a:p>
+            <a:r>
+              <a:rPr lang="en-US" sz="6000" dirty="0"/>
+              <a:t>Preliminary Analysis</a:t>
+            </a:r>
+          </a:p>
+        </p:txBody>
+      </p:sp>
+      <p:sp>
+        <p:nvSpPr>
+          <p:cNvPr id="3" name="Text Placeholder 2"/>
+          <p:cNvSpPr>
+            <a:spLocks noGrp="1"/>
+          </p:cNvSpPr>
+          <p:nvPr>
+            <p:ph type="body" idx="1"/>
+          </p:nvPr>
+        </p:nvSpPr>
+        <p:spPr/>
+        <p:txBody>
+          <a:bodyPr/>
+          <a:lstStyle/>
+          <a:p>
+            <a:endParaRPr lang="en-US"/>
+          </a:p>
+        </p:txBody>
+      </p:sp>
+    </p:spTree>
+    <p:extLst>
+      <p:ext uri="{BB962C8B-B14F-4D97-AF65-F5344CB8AC3E}">
+        <p14:creationId xmlns:p14="http://schemas.microsoft.com/office/powerpoint/2010/main" val="812089888"/>
+      </p:ext>
+    </p:extLst>
+  </p:cSld>
+  <p:clrMapOvr>
+    <a:masterClrMapping/>
+  </p:clrMapOvr>
+</p:sld>
+</file>
+
+<file path=ppt/slides/slide9.xml><?xml version="1.0" encoding="utf-8"?>
+<p:sld xmlns:a="http://schemas.openxmlformats.org/drawingml/2006/main" xmlns:r="http://schemas.openxmlformats.org/officeDocument/2006/relationships" xmlns:p="http://schemas.openxmlformats.org/presentationml/2006/main">
+  <p:cSld>
+    <p:spTree>
+      <p:nvGrpSpPr>
+        <p:cNvPr id="1" name=""/>
+        <p:cNvGrpSpPr/>
+        <p:nvPr/>
+      </p:nvGrpSpPr>
+      <p:grpSpPr>
+        <a:xfrm>
+          <a:off x="0" y="0"/>
+          <a:ext cx="0" cy="0"/>
+          <a:chOff x="0" y="0"/>
+          <a:chExt cx="0" cy="0"/>
+        </a:xfrm>
+      </p:grpSpPr>
+      <p:sp>
+        <p:nvSpPr>
+          <p:cNvPr id="2" name="Title 1"/>
+          <p:cNvSpPr>
+            <a:spLocks noGrp="1"/>
+          </p:cNvSpPr>
+          <p:nvPr>
+            <p:ph type="title"/>
+          </p:nvPr>
+        </p:nvSpPr>
+        <p:spPr/>
+        <p:txBody>
+          <a:bodyPr/>
+          <a:lstStyle/>
+          <a:p>
+            <a:r>
+              <a:rPr lang="en-US" sz="6000" dirty="0"/>
+              <a:t>Model Selection</a:t>
+            </a:r>
+          </a:p>
+        </p:txBody>
+      </p:sp>
+      <p:sp>
+        <p:nvSpPr>
+          <p:cNvPr id="3" name="Text Placeholder 2"/>
+          <p:cNvSpPr>
+            <a:spLocks noGrp="1"/>
+          </p:cNvSpPr>
+          <p:nvPr>
+            <p:ph type="body" idx="1"/>
+          </p:nvPr>
+        </p:nvSpPr>
+        <p:spPr/>
+        <p:txBody>
+          <a:bodyPr/>
+          <a:lstStyle/>
+          <a:p>
+            <a:endParaRPr lang="en-US"/>
+          </a:p>
+        </p:txBody>
+      </p:sp>
+    </p:spTree>
+    <p:extLst>
+      <p:ext uri="{BB962C8B-B14F-4D97-AF65-F5344CB8AC3E}">
+        <p14:creationId xmlns:p14="http://schemas.microsoft.com/office/powerpoint/2010/main" val="3202397597"/>
       </p:ext>
     </p:extLst>
   </p:cSld>

</xml_diff>